<commit_message>
docs(tutorial): add AI-git guide and improve documentation
- Add AI-git操作.md for git workflow tutorial
- Add Tutorial-2 directory with new content
- Improve alt text and formatting in Demo project guide
- Update tutorial PPT files

Co-Authored-By: Claude Opus 4.6 <noreply@anthropic.com>
</commit_message>
<xml_diff>
--- a/Tutorial-0/AI编程Overview.pptx
+++ b/Tutorial-0/AI编程Overview.pptx
@@ -15289,7 +15289,7 @@
                 <a:cs typeface="Noto Sans SC" panose="020B0200000000000000" charset="-122"/>
                 <a:sym typeface="Noto Sans SC" panose="020B0200000000000000" charset="-122"/>
               </a:rPr>
-              <a:t>第一周：Trae基本使用+AGENTS+</a:t>
+              <a:t>第一周：Trae</a:t>
             </a:r>
             <a:r>
               <a:rPr lang="zh-CN" altLang="en-US" sz="1600" b="1" i="0" u="none" strike="noStrike">
@@ -15301,7 +15301,19 @@
                 <a:cs typeface="Noto Sans SC" panose="020B0200000000000000" charset="-122"/>
                 <a:sym typeface="Noto Sans SC" panose="020B0200000000000000" charset="-122"/>
               </a:rPr>
-              <a:t>子代理</a:t>
+              <a:t>试用</a:t>
+            </a:r>
+            <a:r>
+              <a:rPr lang="en-US" sz="1600" b="1" i="0" u="none" strike="noStrike">
+                <a:solidFill>
+                  <a:srgbClr val="000000"/>
+                </a:solidFill>
+                <a:latin typeface="Noto Sans SC" panose="020B0200000000000000" charset="-122"/>
+                <a:ea typeface="Noto Sans SC" panose="020B0200000000000000" charset="-122"/>
+                <a:cs typeface="Noto Sans SC" panose="020B0200000000000000" charset="-122"/>
+                <a:sym typeface="Noto Sans SC" panose="020B0200000000000000" charset="-122"/>
+              </a:rPr>
+              <a:t>+git+AGENTS</a:t>
             </a:r>
             <a:endParaRPr lang="zh-CN" altLang="en-US" sz="1600" b="1" i="0" u="none" strike="noStrike">
               <a:solidFill>
@@ -15448,6 +15460,18 @@
               <a:t>第二周： </a:t>
             </a:r>
             <a:r>
+              <a:rPr lang="zh-CN" altLang="en-US" sz="1600" b="1" i="0" u="none" strike="noStrike">
+                <a:solidFill>
+                  <a:srgbClr val="000000"/>
+                </a:solidFill>
+                <a:latin typeface="Noto Sans SC" panose="020B0200000000000000" charset="-122"/>
+                <a:ea typeface="Noto Sans SC" panose="020B0200000000000000" charset="-122"/>
+                <a:cs typeface="Noto Sans SC" panose="020B0200000000000000" charset="-122"/>
+                <a:sym typeface="Noto Sans SC" panose="020B0200000000000000" charset="-122"/>
+              </a:rPr>
+              <a:t>子代理</a:t>
+            </a:r>
+            <a:r>
               <a:rPr lang="en-US" altLang="zh-CN" sz="1600" b="1" i="0" u="none" strike="noStrike">
                 <a:solidFill>
                   <a:srgbClr val="000000"/>
@@ -15457,7 +15481,7 @@
                 <a:cs typeface="Noto Sans SC" panose="020B0200000000000000" charset="-122"/>
                 <a:sym typeface="Noto Sans SC" panose="020B0200000000000000" charset="-122"/>
               </a:rPr>
-              <a:t>mcp+skill</a:t>
+              <a:t>+mcp+skill</a:t>
             </a:r>
             <a:endParaRPr lang="zh-CN" altLang="en-US" sz="1600" b="1" i="0" u="none" strike="noStrike">
               <a:solidFill>
@@ -15613,6 +15637,30 @@
                 <a:cs typeface="Noto Sans SC" panose="020B0200000000000000" charset="-122"/>
                 <a:sym typeface="Noto Sans SC" panose="020B0200000000000000" charset="-122"/>
               </a:rPr>
+              <a:t>插件</a:t>
+            </a:r>
+            <a:r>
+              <a:rPr lang="en-US" altLang="zh-CN" sz="1600" b="1" i="0" u="none" strike="noStrike">
+                <a:solidFill>
+                  <a:srgbClr val="000000"/>
+                </a:solidFill>
+                <a:latin typeface="Noto Sans SC" panose="020B0200000000000000" charset="-122"/>
+                <a:ea typeface="Noto Sans SC" panose="020B0200000000000000" charset="-122"/>
+                <a:cs typeface="Noto Sans SC" panose="020B0200000000000000" charset="-122"/>
+                <a:sym typeface="Noto Sans SC" panose="020B0200000000000000" charset="-122"/>
+              </a:rPr>
+              <a:t>+</a:t>
+            </a:r>
+            <a:r>
+              <a:rPr lang="zh-CN" altLang="en-US" sz="1600" b="1" i="0" u="none" strike="noStrike">
+                <a:solidFill>
+                  <a:srgbClr val="000000"/>
+                </a:solidFill>
+                <a:latin typeface="Noto Sans SC" panose="020B0200000000000000" charset="-122"/>
+                <a:ea typeface="Noto Sans SC" panose="020B0200000000000000" charset="-122"/>
+                <a:cs typeface="Noto Sans SC" panose="020B0200000000000000" charset="-122"/>
+                <a:sym typeface="Noto Sans SC" panose="020B0200000000000000" charset="-122"/>
+              </a:rPr>
               <a:t>敏捷开发介绍</a:t>
             </a:r>
             <a:endParaRPr lang="zh-CN" altLang="en-US" sz="1600" b="1" i="0" u="none" strike="noStrike">
@@ -15770,6 +15818,30 @@
                 <a:sym typeface="Noto Sans SC" panose="020B0200000000000000" charset="-122"/>
               </a:rPr>
               <a:t>实操</a:t>
+            </a:r>
+            <a:r>
+              <a:rPr lang="en-US" altLang="zh-CN" sz="1600" b="1" i="0" u="none" strike="noStrike">
+                <a:solidFill>
+                  <a:srgbClr val="000000"/>
+                </a:solidFill>
+                <a:latin typeface="Noto Sans SC" panose="020B0200000000000000" charset="-122"/>
+                <a:ea typeface="Noto Sans SC" panose="020B0200000000000000" charset="-122"/>
+                <a:cs typeface="Noto Sans SC" panose="020B0200000000000000" charset="-122"/>
+                <a:sym typeface="Noto Sans SC" panose="020B0200000000000000" charset="-122"/>
+              </a:rPr>
+              <a:t>+</a:t>
+            </a:r>
+            <a:r>
+              <a:rPr lang="zh-CN" altLang="en-US" sz="1600" b="1" i="0" u="none" strike="noStrike">
+                <a:solidFill>
+                  <a:srgbClr val="000000"/>
+                </a:solidFill>
+                <a:latin typeface="Noto Sans SC" panose="020B0200000000000000" charset="-122"/>
+                <a:ea typeface="Noto Sans SC" panose="020B0200000000000000" charset="-122"/>
+                <a:cs typeface="Noto Sans SC" panose="020B0200000000000000" charset="-122"/>
+                <a:sym typeface="Noto Sans SC" panose="020B0200000000000000" charset="-122"/>
+              </a:rPr>
+              <a:t>各种问题</a:t>
             </a:r>
             <a:endParaRPr lang="zh-CN" altLang="en-US" sz="1600" b="1" i="0" u="none" strike="noStrike">
               <a:solidFill>

</xml_diff>